<commit_message>
Refresh presentation progress and record parallel asset takeover
</commit_message>
<xml_diff>
--- a/presentation/output/yuban-gang-project-deck.pptx
+++ b/presentation/output/yuban-gang-project-deck.pptx
@@ -2,25 +2,25 @@
 <file path=ppt/presentation.xml><?xml version="1.0" encoding="utf-8"?>
 <p:presentation xmlns:p="http://schemas.openxmlformats.org/presentationml/2006/main">
   <p:sldMasterIdLst>
-    <p:sldMasterId xmlns:r="http://schemas.openxmlformats.org/officeDocument/2006/relationships" id="2147483648" r:id="R3cd343a0caab4a6b"/>
+    <p:sldMasterId xmlns:r="http://schemas.openxmlformats.org/officeDocument/2006/relationships" id="2147483648" r:id="R19b6b91c2f164b8d"/>
   </p:sldMasterIdLst>
   <p:notesMasterIdLst>
-    <p:notesMasterId xmlns:r="http://schemas.openxmlformats.org/officeDocument/2006/relationships" r:id="R43558fe5604d4e2b"/>
+    <p:notesMasterId xmlns:r="http://schemas.openxmlformats.org/officeDocument/2006/relationships" r:id="R5ec2736bbb734e2a"/>
   </p:notesMasterIdLst>
   <p:sldIdLst>
-    <p:sldId xmlns:r="http://schemas.openxmlformats.org/officeDocument/2006/relationships" id="256" r:id="Rabe3ea475f7f41b3"/>
-    <p:sldId xmlns:r="http://schemas.openxmlformats.org/officeDocument/2006/relationships" id="257" r:id="Rf0df8db042204bba"/>
-    <p:sldId xmlns:r="http://schemas.openxmlformats.org/officeDocument/2006/relationships" id="258" r:id="R9feee7a5b16c4e2d"/>
-    <p:sldId xmlns:r="http://schemas.openxmlformats.org/officeDocument/2006/relationships" id="259" r:id="Re293b6458e8444fe"/>
-    <p:sldId xmlns:r="http://schemas.openxmlformats.org/officeDocument/2006/relationships" id="260" r:id="Raf3ce55e6cb242d6"/>
-    <p:sldId xmlns:r="http://schemas.openxmlformats.org/officeDocument/2006/relationships" id="261" r:id="R91a4984c7e3a4bad"/>
-    <p:sldId xmlns:r="http://schemas.openxmlformats.org/officeDocument/2006/relationships" id="262" r:id="R2a70f9aedfd24797"/>
-    <p:sldId xmlns:r="http://schemas.openxmlformats.org/officeDocument/2006/relationships" id="263" r:id="R20ea0a0f59914ba1"/>
-    <p:sldId xmlns:r="http://schemas.openxmlformats.org/officeDocument/2006/relationships" id="264" r:id="R4b4aed84d2c940bb"/>
-    <p:sldId xmlns:r="http://schemas.openxmlformats.org/officeDocument/2006/relationships" id="265" r:id="R6bb17a07ad904ae5"/>
-    <p:sldId xmlns:r="http://schemas.openxmlformats.org/officeDocument/2006/relationships" id="266" r:id="R08169d5a512b4e5a"/>
-    <p:sldId xmlns:r="http://schemas.openxmlformats.org/officeDocument/2006/relationships" id="267" r:id="Rb75703995ead47bd"/>
-    <p:sldId xmlns:r="http://schemas.openxmlformats.org/officeDocument/2006/relationships" id="268" r:id="Ree34e31c83a8456a"/>
+    <p:sldId xmlns:r="http://schemas.openxmlformats.org/officeDocument/2006/relationships" id="256" r:id="Racce66f4d358475c"/>
+    <p:sldId xmlns:r="http://schemas.openxmlformats.org/officeDocument/2006/relationships" id="257" r:id="Rac5c277c4f564250"/>
+    <p:sldId xmlns:r="http://schemas.openxmlformats.org/officeDocument/2006/relationships" id="258" r:id="Rc508154d58354794"/>
+    <p:sldId xmlns:r="http://schemas.openxmlformats.org/officeDocument/2006/relationships" id="259" r:id="Rf940281c37ca4900"/>
+    <p:sldId xmlns:r="http://schemas.openxmlformats.org/officeDocument/2006/relationships" id="260" r:id="R97b27c08e9c44b50"/>
+    <p:sldId xmlns:r="http://schemas.openxmlformats.org/officeDocument/2006/relationships" id="261" r:id="Rae8982fff6f24fe6"/>
+    <p:sldId xmlns:r="http://schemas.openxmlformats.org/officeDocument/2006/relationships" id="262" r:id="R996ff82f0eb74648"/>
+    <p:sldId xmlns:r="http://schemas.openxmlformats.org/officeDocument/2006/relationships" id="263" r:id="R80bea33283f04806"/>
+    <p:sldId xmlns:r="http://schemas.openxmlformats.org/officeDocument/2006/relationships" id="264" r:id="R073e2de3cce84928"/>
+    <p:sldId xmlns:r="http://schemas.openxmlformats.org/officeDocument/2006/relationships" id="265" r:id="Rbcd61aae38af4866"/>
+    <p:sldId xmlns:r="http://schemas.openxmlformats.org/officeDocument/2006/relationships" id="266" r:id="R9b23191d374e43ee"/>
+    <p:sldId xmlns:r="http://schemas.openxmlformats.org/officeDocument/2006/relationships" id="267" r:id="Rc043497a4fd845dd"/>
+    <p:sldId xmlns:r="http://schemas.openxmlformats.org/officeDocument/2006/relationships" id="268" r:id="R86c796ded7fa47b3"/>
   </p:sldIdLst>
   <p:sldSz cx="12192000" cy="6858000"/>
   <p:notesSz cx="6858000" cy="9144000"/>
@@ -569,27 +569,32 @@
           </a:p>
           <a:p xmlns:a="http://schemas.openxmlformats.org/drawingml/2006/main">
             <a:r>
-              <a:t>artifacts/verification/S02_W01_CHECKS.json</a:t>
-            </a:r>
-          </a:p>
-          <a:p xmlns:a="http://schemas.openxmlformats.org/drawingml/2006/main">
-            <a:r>
-              <a:t>驗證陳述引用既有 S02 證據，本視覺工作包沒有重跑產品測試。</a:t>
-            </a:r>
-          </a:p>
-          <a:p xmlns:a="http://schemas.openxmlformats.org/drawingml/2006/main">
-            <a:r>
-              <a:t>查核基線：9d18bc7e5ffd387b013ae3a3e186d6a73c03275d</a:t>
-            </a:r>
-          </a:p>
-          <a:p xmlns:a="http://schemas.openxmlformats.org/drawingml/2006/main">
-            <a:r>
-              <a:t>artifacts/verification/S02_W01_CHECKS.json</a:t>
-            </a:r>
-          </a:p>
-          <a:p xmlns:a="http://schemas.openxmlformats.org/drawingml/2006/main">
-            <a:r>
-              <a:t>Git merge PR #8</a:t>
+              <a:t>artifacts/verification/S03_W01_CHECKS.json</a:t>
+            </a:r>
+          </a:p>
+          <a:p xmlns:a="http://schemas.openxmlformats.org/drawingml/2006/main">
+            <a:r>
+              <a:t>驗證陳述引用已合併 S06-W03／S03-W01 證據，本素材整合沒有重跑產品測試。</a:t>
+            </a:r>
+          </a:p>
+          <a:p xmlns:a="http://schemas.openxmlformats.org/drawingml/2006/main">
+            <a:r>
+              <a:t>查核基線：39eb5aabe80f09e8c0d44bf58649fa221ad71fc0</a:t>
+            </a:r>
+          </a:p>
+          <a:p xmlns:a="http://schemas.openxmlformats.org/drawingml/2006/main">
+            <a:r>
+              <a:t>artifacts/verification/S06_W03_CHECKS.json</a:t>
+            </a:r>
+          </a:p>
+          <a:p xmlns:a="http://schemas.openxmlformats.org/drawingml/2006/main">
+            <a:r>
+              <a:t>artifacts/verification/S03_W01_CHECKS.json</a:t>
+            </a:r>
+          </a:p>
+          <a:p xmlns:a="http://schemas.openxmlformats.org/drawingml/2006/main">
+            <a:r>
+              <a:t>Git merge PR #10 / #12 / #13</a:t>
             </a:r>
           </a:p>
         </p:txBody>
@@ -1687,7 +1692,7 @@
   </p:cSld>
   <p:clrMap bg1="lt1" tx1="dk1" bg2="lt2" tx2="dk2" accent1="accent1" accent2="accent2" accent3="accent3" accent4="accent4" accent5="accent5" accent6="accent6" hlink="hlink" folHlink="folHlink"/>
   <p:sldLayoutIdLst>
-    <p:sldLayoutId xmlns:r="http://schemas.openxmlformats.org/officeDocument/2006/relationships" id="2147483649" r:id="Rb98960361ad242ec"/>
+    <p:sldLayoutId xmlns:r="http://schemas.openxmlformats.org/officeDocument/2006/relationships" id="2147483649" r:id="R63d285fa03dd4da7"/>
   </p:sldLayoutIdLst>
   <p:txStyles>
     <p:titleStyle>
@@ -2238,7 +2243,7 @@
           <p:cNvPr id="6" name="cover-text-0">
             <a:extLst>
               <a:ext uri="{FF2B5EF4-FFF2-40B4-BE49-F238E27FC236}">
-                <ns2:creationId id="{2192A5AF-85A1-46BF-BF38-33729BAAE1D2}"/>
+                <ns2:creationId id="{50B04642-9459-42CD-9E6A-02CE1170664F}"/>
               </a:ext>
             </a:extLst>
           </p:cNvPr>
@@ -2299,7 +2304,7 @@
           <p:cNvPr id="2" name="cover-text-1">
             <a:extLst>
               <a:ext uri="{FF2B5EF4-FFF2-40B4-BE49-F238E27FC236}">
-                <ns2:creationId id="{A556C7B5-BB39-4D41-A09D-68A7B57D84E8}"/>
+                <ns2:creationId id="{01B95A3A-6EE4-4937-9794-F59261926421}"/>
               </a:ext>
             </a:extLst>
           </p:cNvPr>
@@ -2360,7 +2365,7 @@
           <p:cNvPr id="3" name="cover-text-2">
             <a:extLst>
               <a:ext uri="{FF2B5EF4-FFF2-40B4-BE49-F238E27FC236}">
-                <ns2:creationId id="{C568BB1C-AB7A-469A-908D-C339079D7AAB}"/>
+                <ns2:creationId id="{392387DF-8B89-4598-900B-49965377AD8E}"/>
               </a:ext>
             </a:extLst>
           </p:cNvPr>
@@ -2448,7 +2453,7 @@
           <p:cNvPr id="4" name="cover-text-3">
             <a:extLst>
               <a:ext uri="{FF2B5EF4-FFF2-40B4-BE49-F238E27FC236}">
-                <ns2:creationId id="{79250E82-C679-4D7D-85E8-29107CD09C1A}"/>
+                <ns2:creationId id="{6D663E9F-FB30-4474-91D4-337DF31BA0F5}"/>
               </a:ext>
             </a:extLst>
           </p:cNvPr>
@@ -2513,7 +2518,7 @@
           <p:nvPr/>
         </p:nvPicPr>
         <p:blipFill>
-          <a:blip r:embed="R916854189adb408f">
+          <a:blip r:embed="Re0a391dadd364890">
             <a:extLst>
               <a:ext uri="{96DAC541-7B7A-43D3-8B79-37D633B846F1}">
                 <asvg:svgBlip r:embed="rIdVector1"/>
@@ -2535,7 +2540,7 @@
     </p:spTree>
     <p:extLst>
       <p:ext uri="{BB962C8B-B14F-4D97-AF65-F5344CB8AC3E}">
-        <ns5:creationId val="1991816458"/>
+        <ns5:creationId val="195283415"/>
       </p:ext>
     </p:extLst>
   </p:cSld>
@@ -2566,7 +2571,7 @@
           <p:cNvPr id="15" name="status-text-52">
             <a:extLst xmlns:a="http://schemas.openxmlformats.org/drawingml/2006/main">
               <a:ext uri="{FF2B5EF4-FFF2-40B4-BE49-F238E27FC236}">
-                <a16:creationId xmlns:a16="http://schemas.microsoft.com/office/drawing/2014/main" id="{89BFD433-C773-4A30-AB00-1235327D5F4B}"/>
+                <a16:creationId xmlns:a16="http://schemas.microsoft.com/office/drawing/2014/main" id="{D7436A6F-4269-4178-AA12-26B6B1194C2E}"/>
               </a:ext>
             </a:extLst>
           </p:cNvPr>
@@ -2627,7 +2632,7 @@
           <p:cNvPr id="2" name="status-text-53">
             <a:extLst xmlns:a="http://schemas.openxmlformats.org/drawingml/2006/main">
               <a:ext uri="{FF2B5EF4-FFF2-40B4-BE49-F238E27FC236}">
-                <a16:creationId xmlns:a16="http://schemas.microsoft.com/office/drawing/2014/main" id="{A4678DC0-ED94-426B-9D94-6548405576D4}"/>
+                <a16:creationId xmlns:a16="http://schemas.microsoft.com/office/drawing/2014/main" id="{3E042352-85DA-47DE-8BB9-41B4D5594A45}"/>
               </a:ext>
             </a:extLst>
           </p:cNvPr>
@@ -2678,7 +2683,7 @@
                 <a:ea typeface="Microsoft JhengHei"/>
                 <a:cs typeface="Microsoft JhengHei"/>
               </a:rPr>
-              <a:t>最小 Web 工程已建立</a:t>
+              <a:t>登入、孩子與文字記錄已接通</a:t>
             </a:r>
           </a:p>
         </p:txBody>
@@ -2688,7 +2693,7 @@
           <p:cNvPr id="3" name="status-text-54">
             <a:extLst xmlns:a="http://schemas.openxmlformats.org/drawingml/2006/main">
               <a:ext uri="{FF2B5EF4-FFF2-40B4-BE49-F238E27FC236}">
-                <a16:creationId xmlns:a16="http://schemas.microsoft.com/office/drawing/2014/main" id="{08591EFA-F4E9-4C65-9F19-892937D89EAF}"/>
+                <a16:creationId xmlns:a16="http://schemas.microsoft.com/office/drawing/2014/main" id="{48AA50BE-9218-4138-9329-53D147B9FCD2}"/>
               </a:ext>
             </a:extLst>
           </p:cNvPr>
@@ -2739,7 +2744,7 @@
                 <a:ea typeface="Microsoft JhengHei"/>
                 <a:cs typeface="Microsoft JhengHei"/>
               </a:rPr>
-              <a:t>P1 進行中　S02 已完成並合併；P1 產品流程仍未接通。</a:t>
+              <a:t>P1 暫停待續　S03 已驗收合併，P1 仍未完成。</a:t>
             </a:r>
           </a:p>
         </p:txBody>
@@ -2749,7 +2754,7 @@
           <p:cNvPr id="4" name="status-text-55">
             <a:extLst xmlns:a="http://schemas.openxmlformats.org/drawingml/2006/main">
               <a:ext uri="{FF2B5EF4-FFF2-40B4-BE49-F238E27FC236}">
-                <a16:creationId xmlns:a16="http://schemas.microsoft.com/office/drawing/2014/main" id="{C6D3204A-A03C-470B-87B8-17B26ABD6AF8}"/>
+                <a16:creationId xmlns:a16="http://schemas.microsoft.com/office/drawing/2014/main" id="{C77B9096-574E-4F7C-837A-F44F40DB16CC}"/>
               </a:ext>
             </a:extLst>
           </p:cNvPr>
@@ -2810,7 +2815,7 @@
           <p:cNvPr id="5" name="status-text-56">
             <a:extLst xmlns:a="http://schemas.openxmlformats.org/drawingml/2006/main">
               <a:ext uri="{FF2B5EF4-FFF2-40B4-BE49-F238E27FC236}">
-                <a16:creationId xmlns:a16="http://schemas.microsoft.com/office/drawing/2014/main" id="{870B4662-0DC1-47FB-A2A4-C2A8430EFB54}"/>
+                <a16:creationId xmlns:a16="http://schemas.microsoft.com/office/drawing/2014/main" id="{24A5C2D2-38DB-4A6C-88D4-1226ABE970C9}"/>
               </a:ext>
             </a:extLst>
           </p:cNvPr>
@@ -2861,7 +2866,7 @@
                 <a:ea typeface="Microsoft JhengHei"/>
                 <a:cs typeface="Microsoft JhengHei"/>
               </a:rPr>
-              <a:t>Expo Web 基礎畫面</a:t>
+              <a:t>Web 註冊／登入及帳號隔離</a:t>
             </a:r>
           </a:p>
         </p:txBody>
@@ -2871,7 +2876,7 @@
           <p:cNvPr id="6" name="status-text-57">
             <a:extLst xmlns:a="http://schemas.openxmlformats.org/drawingml/2006/main">
               <a:ext uri="{FF2B5EF4-FFF2-40B4-BE49-F238E27FC236}">
-                <a16:creationId xmlns:a16="http://schemas.microsoft.com/office/drawing/2014/main" id="{E8E4DDAE-0189-471C-85FE-E8326DA37328}"/>
+                <a16:creationId xmlns:a16="http://schemas.microsoft.com/office/drawing/2014/main" id="{E46D98A9-9A50-4872-AF10-6FA3917FB134}"/>
               </a:ext>
             </a:extLst>
           </p:cNvPr>
@@ -2922,7 +2927,7 @@
                 <a:ea typeface="Microsoft JhengHei"/>
                 <a:cs typeface="Microsoft JhengHei"/>
               </a:rPr>
-              <a:t>孩子稱呼／文字記錄輸入驗證</a:t>
+              <a:t>建立／切換孩子、確認保存文字記錄</a:t>
             </a:r>
           </a:p>
         </p:txBody>
@@ -2932,7 +2937,7 @@
           <p:cNvPr id="7" name="status-text-58">
             <a:extLst xmlns:a="http://schemas.openxmlformats.org/drawingml/2006/main">
               <a:ext uri="{FF2B5EF4-FFF2-40B4-BE49-F238E27FC236}">
-                <a16:creationId xmlns:a16="http://schemas.microsoft.com/office/drawing/2014/main" id="{1A00BC4C-0412-4524-A239-C9018E33DAF4}"/>
+                <a16:creationId xmlns:a16="http://schemas.microsoft.com/office/drawing/2014/main" id="{8DF50379-9C33-428C-838A-04CB41822628}"/>
               </a:ext>
             </a:extLst>
           </p:cNvPr>
@@ -2983,7 +2988,7 @@
                 <a:ea typeface="Microsoft JhengHei"/>
                 <a:cs typeface="Microsoft JhengHei"/>
               </a:rPr>
-              <a:t>可配置的公開 API 地址</a:t>
+              <a:t>PostgreSQL 保存，重開後可恢復</a:t>
             </a:r>
           </a:p>
         </p:txBody>
@@ -2993,7 +2998,7 @@
           <p:cNvPr id="8" name="status-text-59">
             <a:extLst xmlns:a="http://schemas.openxmlformats.org/drawingml/2006/main">
               <a:ext uri="{FF2B5EF4-FFF2-40B4-BE49-F238E27FC236}">
-                <a16:creationId xmlns:a16="http://schemas.microsoft.com/office/drawing/2014/main" id="{45466535-22F8-4BA0-B3E7-C4E8F17A2C9C}"/>
+                <a16:creationId xmlns:a16="http://schemas.microsoft.com/office/drawing/2014/main" id="{E058F4F0-F0CB-4449-93F7-E8EDCD3C103C}"/>
               </a:ext>
             </a:extLst>
           </p:cNvPr>
@@ -3054,7 +3059,7 @@
           <p:cNvPr id="9" name="status-text-60">
             <a:extLst xmlns:a="http://schemas.openxmlformats.org/drawingml/2006/main">
               <a:ext uri="{FF2B5EF4-FFF2-40B4-BE49-F238E27FC236}">
-                <a16:creationId xmlns:a16="http://schemas.microsoft.com/office/drawing/2014/main" id="{6AA92E33-EEC2-4CFD-AE55-1DE010012842}"/>
+                <a16:creationId xmlns:a16="http://schemas.microsoft.com/office/drawing/2014/main" id="{49F2CEEE-95CE-404B-8EA1-2F0E76FCB5DC}"/>
               </a:ext>
             </a:extLst>
           </p:cNvPr>
@@ -3105,7 +3110,7 @@
                 <a:ea typeface="Microsoft JhengHei"/>
                 <a:cs typeface="Microsoft JhengHei"/>
               </a:rPr>
-              <a:t>登入與 Server 持久保存</a:t>
+              <a:t>安全 AI API、聊天與真 Gemini</a:t>
             </a:r>
           </a:p>
         </p:txBody>
@@ -3115,7 +3120,7 @@
           <p:cNvPr id="10" name="status-text-61">
             <a:extLst xmlns:a="http://schemas.openxmlformats.org/drawingml/2006/main">
               <a:ext uri="{FF2B5EF4-FFF2-40B4-BE49-F238E27FC236}">
-                <a16:creationId xmlns:a16="http://schemas.microsoft.com/office/drawing/2014/main" id="{337821F6-FD6B-4981-B211-5E7752CB0CAD}"/>
+                <a16:creationId xmlns:a16="http://schemas.microsoft.com/office/drawing/2014/main" id="{E95E0721-DB7E-432B-8002-ABCFE696C37A}"/>
               </a:ext>
             </a:extLst>
           </p:cNvPr>
@@ -3166,7 +3171,7 @@
                 <a:ea typeface="Microsoft JhengHei"/>
                 <a:cs typeface="Microsoft JhengHei"/>
               </a:rPr>
-              <a:t>原始聊天與真 Gemini</a:t>
+              <a:t>儲存加密及最小備份還原</a:t>
             </a:r>
           </a:p>
         </p:txBody>
@@ -3176,7 +3181,7 @@
           <p:cNvPr id="11" name="status-text-62">
             <a:extLst xmlns:a="http://schemas.openxmlformats.org/drawingml/2006/main">
               <a:ext uri="{FF2B5EF4-FFF2-40B4-BE49-F238E27FC236}">
-                <a16:creationId xmlns:a16="http://schemas.microsoft.com/office/drawing/2014/main" id="{E015C0C6-0FDC-4321-A151-3DC9A316AA59}"/>
+                <a16:creationId xmlns:a16="http://schemas.microsoft.com/office/drawing/2014/main" id="{53FBFCB9-2269-4A0F-A8D5-C4120CB14FE3}"/>
               </a:ext>
             </a:extLst>
           </p:cNvPr>
@@ -3227,7 +3232,7 @@
                 <a:ea typeface="Microsoft JhengHei"/>
                 <a:cs typeface="Microsoft JhengHei"/>
               </a:rPr>
-              <a:t>加密備份還原與獨立試玩 URL</a:t>
+              <a:t>部署與組員獨立試玩 URL</a:t>
             </a:r>
           </a:p>
         </p:txBody>
@@ -3237,7 +3242,7 @@
           <p:cNvPr id="12" name="">
             <a:extLst xmlns:a="http://schemas.openxmlformats.org/drawingml/2006/main">
               <a:ext uri="{FF2B5EF4-FFF2-40B4-BE49-F238E27FC236}">
-                <a16:creationId xmlns:a16="http://schemas.microsoft.com/office/drawing/2014/main" id="{8A364421-860F-4013-B337-EA1C31D894FD}"/>
+                <a16:creationId xmlns:a16="http://schemas.microsoft.com/office/drawing/2014/main" id="{51F8DDBB-6ABD-47AF-934C-B141FEFA3088}"/>
               </a:ext>
             </a:extLst>
           </p:cNvPr>
@@ -3267,7 +3272,7 @@
           <p:cNvPr id="13" name="status-text-63">
             <a:extLst xmlns:a="http://schemas.openxmlformats.org/drawingml/2006/main">
               <a:ext uri="{FF2B5EF4-FFF2-40B4-BE49-F238E27FC236}">
-                <a16:creationId xmlns:a16="http://schemas.microsoft.com/office/drawing/2014/main" id="{8A1FABD3-E6E3-46DC-9F5A-CC699336A7D4}"/>
+                <a16:creationId xmlns:a16="http://schemas.microsoft.com/office/drawing/2014/main" id="{BD206BA8-B66A-4486-8B8B-7D0FB53CFF9D}"/>
               </a:ext>
             </a:extLst>
           </p:cNvPr>
@@ -3318,7 +3323,7 @@
                 <a:ea typeface="Microsoft JhengHei"/>
                 <a:cs typeface="Microsoft JhengHei"/>
               </a:rPr>
-              <a:t>已有驗證證據：已記錄 8／8 單元測試通過；已記錄 typecheck、Web export 及本機啟動通過</a:t>
+              <a:t>已有驗證證據：64 項單元、16 項 HTTP、12 項 Web E2E 通過；typecheck 及 Web export 通過</a:t>
             </a:r>
           </a:p>
         </p:txBody>
@@ -3328,7 +3333,7 @@
           <p:cNvPr id="14" name="status-text-64">
             <a:extLst xmlns:a="http://schemas.openxmlformats.org/drawingml/2006/main">
               <a:ext uri="{FF2B5EF4-FFF2-40B4-BE49-F238E27FC236}">
-                <a16:creationId xmlns:a16="http://schemas.microsoft.com/office/drawing/2014/main" id="{72FB4016-1A73-4E22-A283-2EA8A03DBADE}"/>
+                <a16:creationId xmlns:a16="http://schemas.microsoft.com/office/drawing/2014/main" id="{9E654B3F-86E1-436D-9A26-FF47F2A6F5C5}"/>
               </a:ext>
             </a:extLst>
           </p:cNvPr>
@@ -3379,7 +3384,7 @@
                 <a:ea typeface="Microsoft JhengHei"/>
                 <a:cs typeface="Microsoft JhengHei"/>
               </a:rPr>
-              <a:t>2026-09-22　基線 9d18bc7　Demo 連結待提供</a:t>
+              <a:t>2026-09-22　基線 39eb5aa　Demo 連結待提供</a:t>
             </a:r>
           </a:p>
         </p:txBody>
@@ -3387,7 +3392,7 @@
     </p:spTree>
     <p:extLst>
       <p:ext uri="{BB962C8B-B14F-4D97-AF65-F5344CB8AC3E}">
-        <p14:creationId xmlns:p14="http://schemas.microsoft.com/office/powerpoint/2010/main" val="2080065580"/>
+        <p14:creationId xmlns:p14="http://schemas.microsoft.com/office/powerpoint/2010/main" val="1610299775"/>
       </p:ext>
     </p:extLst>
   </p:cSld>
@@ -3418,7 +3423,7 @@
           <p:cNvPr id="27" name="demo-text-65">
             <a:extLst xmlns:a="http://schemas.openxmlformats.org/drawingml/2006/main">
               <a:ext uri="{FF2B5EF4-FFF2-40B4-BE49-F238E27FC236}">
-                <a16:creationId xmlns:a16="http://schemas.microsoft.com/office/drawing/2014/main" id="{41FED88A-2DD4-4B3F-9372-1E7813419B5D}"/>
+                <a16:creationId xmlns:a16="http://schemas.microsoft.com/office/drawing/2014/main" id="{77D68B2C-906B-4418-A0B6-30ABC794F008}"/>
               </a:ext>
             </a:extLst>
           </p:cNvPr>
@@ -3479,7 +3484,7 @@
           <p:cNvPr id="2" name="demo-text-66">
             <a:extLst xmlns:a="http://schemas.openxmlformats.org/drawingml/2006/main">
               <a:ext uri="{FF2B5EF4-FFF2-40B4-BE49-F238E27FC236}">
-                <a16:creationId xmlns:a16="http://schemas.microsoft.com/office/drawing/2014/main" id="{685CCDEA-0761-4E4B-BB86-191B63B3459E}"/>
+                <a16:creationId xmlns:a16="http://schemas.microsoft.com/office/drawing/2014/main" id="{7F1747E3-7F2B-4E77-BF36-E8F96347845B}"/>
               </a:ext>
             </a:extLst>
           </p:cNvPr>
@@ -3540,7 +3545,7 @@
           <p:cNvPr id="3" name="">
             <a:extLst xmlns:a="http://schemas.openxmlformats.org/drawingml/2006/main">
               <a:ext uri="{FF2B5EF4-FFF2-40B4-BE49-F238E27FC236}">
-                <a16:creationId xmlns:a16="http://schemas.microsoft.com/office/drawing/2014/main" id="{780823CA-CD3B-45E5-B193-2ED59439C180}"/>
+                <a16:creationId xmlns:a16="http://schemas.microsoft.com/office/drawing/2014/main" id="{810B5F75-11DE-42C3-A92A-D054E3D0AB55}"/>
               </a:ext>
             </a:extLst>
           </p:cNvPr>
@@ -3570,7 +3575,7 @@
           <p:cNvPr id="4" name="demo-text-67">
             <a:extLst xmlns:a="http://schemas.openxmlformats.org/drawingml/2006/main">
               <a:ext uri="{FF2B5EF4-FFF2-40B4-BE49-F238E27FC236}">
-                <a16:creationId xmlns:a16="http://schemas.microsoft.com/office/drawing/2014/main" id="{7ED17CAE-472E-4763-A3CC-AEEBBCD869C7}"/>
+                <a16:creationId xmlns:a16="http://schemas.microsoft.com/office/drawing/2014/main" id="{C45D1823-39DA-4F8B-9B75-A4F687F4ADDB}"/>
               </a:ext>
             </a:extLst>
           </p:cNvPr>
@@ -3631,7 +3636,7 @@
           <p:cNvPr id="5" name="demo-text-68">
             <a:extLst xmlns:a="http://schemas.openxmlformats.org/drawingml/2006/main">
               <a:ext uri="{FF2B5EF4-FFF2-40B4-BE49-F238E27FC236}">
-                <a16:creationId xmlns:a16="http://schemas.microsoft.com/office/drawing/2014/main" id="{E18ED4F2-8D57-4EC2-BC31-6A79C9D889FB}"/>
+                <a16:creationId xmlns:a16="http://schemas.microsoft.com/office/drawing/2014/main" id="{EF72ED87-C062-4AE4-B8DD-7E91B66EA3C2}"/>
               </a:ext>
             </a:extLst>
           </p:cNvPr>
@@ -3692,7 +3697,7 @@
           <p:cNvPr id="6" name="demo-text-69">
             <a:extLst xmlns:a="http://schemas.openxmlformats.org/drawingml/2006/main">
               <a:ext uri="{FF2B5EF4-FFF2-40B4-BE49-F238E27FC236}">
-                <a16:creationId xmlns:a16="http://schemas.microsoft.com/office/drawing/2014/main" id="{C056DA0C-D8FF-49CD-940C-B47D0A808932}"/>
+                <a16:creationId xmlns:a16="http://schemas.microsoft.com/office/drawing/2014/main" id="{1B7C95D0-0BF0-4E98-9965-0694C20183CB}"/>
               </a:ext>
             </a:extLst>
           </p:cNvPr>
@@ -3753,7 +3758,7 @@
           <p:cNvPr id="7" name="">
             <a:extLst xmlns:a="http://schemas.openxmlformats.org/drawingml/2006/main">
               <a:ext uri="{FF2B5EF4-FFF2-40B4-BE49-F238E27FC236}">
-                <a16:creationId xmlns:a16="http://schemas.microsoft.com/office/drawing/2014/main" id="{10B834C4-D6C3-4363-A871-67556CC08369}"/>
+                <a16:creationId xmlns:a16="http://schemas.microsoft.com/office/drawing/2014/main" id="{AF9A7D21-77E8-48F9-ADFE-7D2637B09C0C}"/>
               </a:ext>
             </a:extLst>
           </p:cNvPr>
@@ -3783,7 +3788,7 @@
           <p:cNvPr id="8" name="demo-text-70">
             <a:extLst xmlns:a="http://schemas.openxmlformats.org/drawingml/2006/main">
               <a:ext uri="{FF2B5EF4-FFF2-40B4-BE49-F238E27FC236}">
-                <a16:creationId xmlns:a16="http://schemas.microsoft.com/office/drawing/2014/main" id="{C8C66511-4CAF-4477-BFD7-5C42A1ADBF13}"/>
+                <a16:creationId xmlns:a16="http://schemas.microsoft.com/office/drawing/2014/main" id="{D0D64B4D-F42E-4462-9C7F-A406F2B17A3A}"/>
               </a:ext>
             </a:extLst>
           </p:cNvPr>
@@ -3844,7 +3849,7 @@
           <p:cNvPr id="9" name="demo-text-71">
             <a:extLst xmlns:a="http://schemas.openxmlformats.org/drawingml/2006/main">
               <a:ext uri="{FF2B5EF4-FFF2-40B4-BE49-F238E27FC236}">
-                <a16:creationId xmlns:a16="http://schemas.microsoft.com/office/drawing/2014/main" id="{9E0203F2-EA9C-4E96-BA99-9FD57AC6F775}"/>
+                <a16:creationId xmlns:a16="http://schemas.microsoft.com/office/drawing/2014/main" id="{C71B5ACC-F636-4B62-B0E0-07ACB09B5535}"/>
               </a:ext>
             </a:extLst>
           </p:cNvPr>
@@ -3905,7 +3910,7 @@
           <p:cNvPr id="10" name="demo-text-72">
             <a:extLst xmlns:a="http://schemas.openxmlformats.org/drawingml/2006/main">
               <a:ext uri="{FF2B5EF4-FFF2-40B4-BE49-F238E27FC236}">
-                <a16:creationId xmlns:a16="http://schemas.microsoft.com/office/drawing/2014/main" id="{5FEAE751-C679-4A74-91A6-93C206F1ED64}"/>
+                <a16:creationId xmlns:a16="http://schemas.microsoft.com/office/drawing/2014/main" id="{13358247-8A39-4485-9D90-603AE6B20775}"/>
               </a:ext>
             </a:extLst>
           </p:cNvPr>
@@ -3966,7 +3971,7 @@
           <p:cNvPr id="11" name="">
             <a:extLst xmlns:a="http://schemas.openxmlformats.org/drawingml/2006/main">
               <a:ext uri="{FF2B5EF4-FFF2-40B4-BE49-F238E27FC236}">
-                <a16:creationId xmlns:a16="http://schemas.microsoft.com/office/drawing/2014/main" id="{D167359B-1256-4E16-A2B9-786774516A05}"/>
+                <a16:creationId xmlns:a16="http://schemas.microsoft.com/office/drawing/2014/main" id="{186D0934-4B03-4921-AE84-681C41F70EB6}"/>
               </a:ext>
             </a:extLst>
           </p:cNvPr>
@@ -3996,7 +4001,7 @@
           <p:cNvPr id="12" name="demo-text-73">
             <a:extLst xmlns:a="http://schemas.openxmlformats.org/drawingml/2006/main">
               <a:ext uri="{FF2B5EF4-FFF2-40B4-BE49-F238E27FC236}">
-                <a16:creationId xmlns:a16="http://schemas.microsoft.com/office/drawing/2014/main" id="{E766A5E7-7013-4684-8238-1D94C6612ED0}"/>
+                <a16:creationId xmlns:a16="http://schemas.microsoft.com/office/drawing/2014/main" id="{86EA2BD6-6E1C-405B-BA0D-14A2F6637526}"/>
               </a:ext>
             </a:extLst>
           </p:cNvPr>
@@ -4057,7 +4062,7 @@
           <p:cNvPr id="13" name="demo-text-74">
             <a:extLst xmlns:a="http://schemas.openxmlformats.org/drawingml/2006/main">
               <a:ext uri="{FF2B5EF4-FFF2-40B4-BE49-F238E27FC236}">
-                <a16:creationId xmlns:a16="http://schemas.microsoft.com/office/drawing/2014/main" id="{70F1E3A7-2294-4962-BCE4-0B00297078EC}"/>
+                <a16:creationId xmlns:a16="http://schemas.microsoft.com/office/drawing/2014/main" id="{70A94138-0DF2-42DB-865F-4C97FE518F49}"/>
               </a:ext>
             </a:extLst>
           </p:cNvPr>
@@ -4118,7 +4123,7 @@
           <p:cNvPr id="14" name="demo-text-75">
             <a:extLst xmlns:a="http://schemas.openxmlformats.org/drawingml/2006/main">
               <a:ext uri="{FF2B5EF4-FFF2-40B4-BE49-F238E27FC236}">
-                <a16:creationId xmlns:a16="http://schemas.microsoft.com/office/drawing/2014/main" id="{2AAADEF6-6B0E-4671-8700-CE596163DA43}"/>
+                <a16:creationId xmlns:a16="http://schemas.microsoft.com/office/drawing/2014/main" id="{94D8EDD2-6089-4250-91D6-91F935F1782A}"/>
               </a:ext>
             </a:extLst>
           </p:cNvPr>
@@ -4179,7 +4184,7 @@
           <p:cNvPr id="15" name="">
             <a:extLst xmlns:a="http://schemas.openxmlformats.org/drawingml/2006/main">
               <a:ext uri="{FF2B5EF4-FFF2-40B4-BE49-F238E27FC236}">
-                <a16:creationId xmlns:a16="http://schemas.microsoft.com/office/drawing/2014/main" id="{53917CD4-FFA0-415E-90DD-6360DE9F9BA1}"/>
+                <a16:creationId xmlns:a16="http://schemas.microsoft.com/office/drawing/2014/main" id="{2EAC8B67-9D26-4ED1-B5AA-9689AB678C64}"/>
               </a:ext>
             </a:extLst>
           </p:cNvPr>
@@ -4209,7 +4214,7 @@
           <p:cNvPr id="16" name="demo-text-76">
             <a:extLst xmlns:a="http://schemas.openxmlformats.org/drawingml/2006/main">
               <a:ext uri="{FF2B5EF4-FFF2-40B4-BE49-F238E27FC236}">
-                <a16:creationId xmlns:a16="http://schemas.microsoft.com/office/drawing/2014/main" id="{D21EA5DE-9458-4FED-B31E-06BBF6B56543}"/>
+                <a16:creationId xmlns:a16="http://schemas.microsoft.com/office/drawing/2014/main" id="{86626F97-F05B-42AF-91B5-68813F08E698}"/>
               </a:ext>
             </a:extLst>
           </p:cNvPr>
@@ -4270,7 +4275,7 @@
           <p:cNvPr id="17" name="demo-text-77">
             <a:extLst xmlns:a="http://schemas.openxmlformats.org/drawingml/2006/main">
               <a:ext uri="{FF2B5EF4-FFF2-40B4-BE49-F238E27FC236}">
-                <a16:creationId xmlns:a16="http://schemas.microsoft.com/office/drawing/2014/main" id="{C3959414-25D8-46C0-94B2-46F9A76C1A7C}"/>
+                <a16:creationId xmlns:a16="http://schemas.microsoft.com/office/drawing/2014/main" id="{8FDF4C3C-FB2E-4B54-9DBB-F2F204284F05}"/>
               </a:ext>
             </a:extLst>
           </p:cNvPr>
@@ -4331,7 +4336,7 @@
           <p:cNvPr id="18" name="demo-text-78">
             <a:extLst xmlns:a="http://schemas.openxmlformats.org/drawingml/2006/main">
               <a:ext uri="{FF2B5EF4-FFF2-40B4-BE49-F238E27FC236}">
-                <a16:creationId xmlns:a16="http://schemas.microsoft.com/office/drawing/2014/main" id="{13AC7E59-6122-4A09-8A04-3027BEA2C51E}"/>
+                <a16:creationId xmlns:a16="http://schemas.microsoft.com/office/drawing/2014/main" id="{C164B224-0AC4-479F-8ED1-5C0B058BDA0F}"/>
               </a:ext>
             </a:extLst>
           </p:cNvPr>
@@ -4392,7 +4397,7 @@
           <p:cNvPr id="19" name="">
             <a:extLst xmlns:a="http://schemas.openxmlformats.org/drawingml/2006/main">
               <a:ext uri="{FF2B5EF4-FFF2-40B4-BE49-F238E27FC236}">
-                <a16:creationId xmlns:a16="http://schemas.microsoft.com/office/drawing/2014/main" id="{979EDC94-D1DC-43F7-8E32-7997F9BEF636}"/>
+                <a16:creationId xmlns:a16="http://schemas.microsoft.com/office/drawing/2014/main" id="{5D44D67B-C735-49A5-9D24-20701BFD03D2}"/>
               </a:ext>
             </a:extLst>
           </p:cNvPr>
@@ -4422,7 +4427,7 @@
           <p:cNvPr id="20" name="demo-text-79">
             <a:extLst xmlns:a="http://schemas.openxmlformats.org/drawingml/2006/main">
               <a:ext uri="{FF2B5EF4-FFF2-40B4-BE49-F238E27FC236}">
-                <a16:creationId xmlns:a16="http://schemas.microsoft.com/office/drawing/2014/main" id="{DD01CFBF-2EB1-4C69-A79C-877A5152A6A7}"/>
+                <a16:creationId xmlns:a16="http://schemas.microsoft.com/office/drawing/2014/main" id="{4BDA3769-D8E5-4430-BB14-FED1DBCAFDBF}"/>
               </a:ext>
             </a:extLst>
           </p:cNvPr>
@@ -4483,7 +4488,7 @@
           <p:cNvPr id="21" name="demo-text-80">
             <a:extLst xmlns:a="http://schemas.openxmlformats.org/drawingml/2006/main">
               <a:ext uri="{FF2B5EF4-FFF2-40B4-BE49-F238E27FC236}">
-                <a16:creationId xmlns:a16="http://schemas.microsoft.com/office/drawing/2014/main" id="{ADBF433C-965C-4DFD-BA1C-9960D00BDAC1}"/>
+                <a16:creationId xmlns:a16="http://schemas.microsoft.com/office/drawing/2014/main" id="{C5356935-993C-4FE6-8F62-92950EDFA6EA}"/>
               </a:ext>
             </a:extLst>
           </p:cNvPr>
@@ -4544,7 +4549,7 @@
           <p:cNvPr id="22" name="demo-text-81">
             <a:extLst xmlns:a="http://schemas.openxmlformats.org/drawingml/2006/main">
               <a:ext uri="{FF2B5EF4-FFF2-40B4-BE49-F238E27FC236}">
-                <a16:creationId xmlns:a16="http://schemas.microsoft.com/office/drawing/2014/main" id="{BBF632F1-2E57-4C8C-A86B-0F3788ED3006}"/>
+                <a16:creationId xmlns:a16="http://schemas.microsoft.com/office/drawing/2014/main" id="{DA51E015-6D5A-4156-A9D7-206C0A4C039B}"/>
               </a:ext>
             </a:extLst>
           </p:cNvPr>
@@ -4605,7 +4610,7 @@
           <p:cNvPr id="23" name="">
             <a:extLst xmlns:a="http://schemas.openxmlformats.org/drawingml/2006/main">
               <a:ext uri="{FF2B5EF4-FFF2-40B4-BE49-F238E27FC236}">
-                <a16:creationId xmlns:a16="http://schemas.microsoft.com/office/drawing/2014/main" id="{DAC2F6ED-4E22-4DCD-9977-B3C7514B355F}"/>
+                <a16:creationId xmlns:a16="http://schemas.microsoft.com/office/drawing/2014/main" id="{E7EB1F36-5A93-4E54-BA83-4E569A9E295F}"/>
               </a:ext>
             </a:extLst>
           </p:cNvPr>
@@ -4635,7 +4640,7 @@
           <p:cNvPr id="24" name="demo-text-82">
             <a:extLst xmlns:a="http://schemas.openxmlformats.org/drawingml/2006/main">
               <a:ext uri="{FF2B5EF4-FFF2-40B4-BE49-F238E27FC236}">
-                <a16:creationId xmlns:a16="http://schemas.microsoft.com/office/drawing/2014/main" id="{AF8C4519-BEDE-444F-A107-CD2D6E06EEB2}"/>
+                <a16:creationId xmlns:a16="http://schemas.microsoft.com/office/drawing/2014/main" id="{5B54A737-2815-4DE9-B92D-2DDA8F1425A4}"/>
               </a:ext>
             </a:extLst>
           </p:cNvPr>
@@ -4696,7 +4701,7 @@
           <p:cNvPr id="25" name="demo-text-83">
             <a:extLst xmlns:a="http://schemas.openxmlformats.org/drawingml/2006/main">
               <a:ext uri="{FF2B5EF4-FFF2-40B4-BE49-F238E27FC236}">
-                <a16:creationId xmlns:a16="http://schemas.microsoft.com/office/drawing/2014/main" id="{C8411233-80BD-4695-A3C4-086B84139EEA}"/>
+                <a16:creationId xmlns:a16="http://schemas.microsoft.com/office/drawing/2014/main" id="{54EB798E-7E28-441F-BB6C-10CAF9A61243}"/>
               </a:ext>
             </a:extLst>
           </p:cNvPr>
@@ -4757,7 +4762,7 @@
           <p:cNvPr id="26" name="demo-text-84">
             <a:extLst xmlns:a="http://schemas.openxmlformats.org/drawingml/2006/main">
               <a:ext uri="{FF2B5EF4-FFF2-40B4-BE49-F238E27FC236}">
-                <a16:creationId xmlns:a16="http://schemas.microsoft.com/office/drawing/2014/main" id="{0FC17583-D02A-4675-AA45-948584CF405A}"/>
+                <a16:creationId xmlns:a16="http://schemas.microsoft.com/office/drawing/2014/main" id="{1938B1BC-E5C4-494C-9F72-9B099A717390}"/>
               </a:ext>
             </a:extLst>
           </p:cNvPr>
@@ -4816,7 +4821,7 @@
     </p:spTree>
     <p:extLst>
       <p:ext uri="{BB962C8B-B14F-4D97-AF65-F5344CB8AC3E}">
-        <p14:creationId xmlns:p14="http://schemas.microsoft.com/office/powerpoint/2010/main" val="570226621"/>
+        <p14:creationId xmlns:p14="http://schemas.microsoft.com/office/powerpoint/2010/main" val="890355404"/>
       </p:ext>
     </p:extLst>
   </p:cSld>
@@ -4847,7 +4852,7 @@
           <p:cNvPr id="15" name="growth-text-85">
             <a:extLst>
               <a:ext uri="{FF2B5EF4-FFF2-40B4-BE49-F238E27FC236}">
-                <ns2:creationId id="{521B3369-AEDF-4749-BD34-5D012D206A7B}"/>
+                <ns2:creationId id="{E30FCA85-72AC-4F5D-B497-B12CEF5351BD}"/>
               </a:ext>
             </a:extLst>
           </p:cNvPr>
@@ -4908,7 +4913,7 @@
           <p:cNvPr id="2" name="growth-text-86">
             <a:extLst>
               <a:ext uri="{FF2B5EF4-FFF2-40B4-BE49-F238E27FC236}">
-                <ns2:creationId id="{1FD7B05F-16A8-4292-AAB8-EEBB1A4FB9C4}"/>
+                <ns2:creationId id="{F8308431-5F22-443B-A7E0-B7BF4B59CC4F}"/>
               </a:ext>
             </a:extLst>
           </p:cNvPr>
@@ -4969,7 +4974,7 @@
           <p:cNvPr id="3" name="">
             <a:extLst>
               <a:ext uri="{FF2B5EF4-FFF2-40B4-BE49-F238E27FC236}">
-                <ns2:creationId id="{4E89184E-F8A5-4745-AB51-7B746A7D9B0F}"/>
+                <ns2:creationId id="{59FBFCCD-5F3A-4995-9D88-4BEBA63EF310}"/>
               </a:ext>
             </a:extLst>
           </p:cNvPr>
@@ -4999,7 +5004,7 @@
           <p:cNvPr id="4" name="growth-text-87">
             <a:extLst>
               <a:ext uri="{FF2B5EF4-FFF2-40B4-BE49-F238E27FC236}">
-                <ns2:creationId id="{DF1EC309-BA78-4508-A3BE-4014AEEE9D26}"/>
+                <ns2:creationId id="{3804302C-EAC4-431F-BACB-60F41B4551DC}"/>
               </a:ext>
             </a:extLst>
           </p:cNvPr>
@@ -5060,7 +5065,7 @@
           <p:cNvPr id="5" name="">
             <a:extLst>
               <a:ext uri="{FF2B5EF4-FFF2-40B4-BE49-F238E27FC236}">
-                <ns2:creationId id="{7D6E99B0-1982-427C-8102-4C34C9602443}"/>
+                <ns2:creationId id="{365B394E-61AE-401F-BBBD-92294E78EFB8}"/>
               </a:ext>
             </a:extLst>
           </p:cNvPr>
@@ -5090,7 +5095,7 @@
           <p:cNvPr id="6" name="growth-text-88">
             <a:extLst>
               <a:ext uri="{FF2B5EF4-FFF2-40B4-BE49-F238E27FC236}">
-                <ns2:creationId id="{1EBA48C9-9BDD-4C70-8652-6F9F1B27A820}"/>
+                <ns2:creationId id="{FC2B0FDD-C16F-4E72-98EE-F2667BD3E2E2}"/>
               </a:ext>
             </a:extLst>
           </p:cNvPr>
@@ -5151,7 +5156,7 @@
           <p:cNvPr id="7" name="">
             <a:extLst>
               <a:ext uri="{FF2B5EF4-FFF2-40B4-BE49-F238E27FC236}">
-                <ns2:creationId id="{7AE98CCD-8778-45A6-8A7B-99FFAA86BE62}"/>
+                <ns2:creationId id="{BF8A5DFA-6BA9-4987-9643-FBC6ADB4A405}"/>
               </a:ext>
             </a:extLst>
           </p:cNvPr>
@@ -5181,7 +5186,7 @@
           <p:cNvPr id="8" name="growth-text-89">
             <a:extLst>
               <a:ext uri="{FF2B5EF4-FFF2-40B4-BE49-F238E27FC236}">
-                <ns2:creationId id="{21C1AF62-74F4-4A4C-B21B-2EC8FA6CAA3F}"/>
+                <ns2:creationId id="{8A9C7E00-0423-4215-B2D1-62CC3FFA7B8F}"/>
               </a:ext>
             </a:extLst>
           </p:cNvPr>
@@ -5242,7 +5247,7 @@
           <p:cNvPr id="9" name="">
             <a:extLst>
               <a:ext uri="{FF2B5EF4-FFF2-40B4-BE49-F238E27FC236}">
-                <ns2:creationId id="{1633F69D-D6B2-4C3C-8B7D-5AB7221B980A}"/>
+                <ns2:creationId id="{10F9029C-59B8-40B7-A3ED-A161FF240F1E}"/>
               </a:ext>
             </a:extLst>
           </p:cNvPr>
@@ -5272,7 +5277,7 @@
           <p:cNvPr id="10" name="growth-text-90">
             <a:extLst>
               <a:ext uri="{FF2B5EF4-FFF2-40B4-BE49-F238E27FC236}">
-                <ns2:creationId id="{867B2A1F-E149-48D9-99C5-3B34310BCE79}"/>
+                <ns2:creationId id="{7D6CEDD7-0BC0-43A4-A56E-3A61286C6EFD}"/>
               </a:ext>
             </a:extLst>
           </p:cNvPr>
@@ -5333,7 +5338,7 @@
           <p:cNvPr id="11" name="growth-text-91">
             <a:extLst>
               <a:ext uri="{FF2B5EF4-FFF2-40B4-BE49-F238E27FC236}">
-                <ns2:creationId id="{1A741598-F3D4-45B1-947D-76F21E5A47DA}"/>
+                <ns2:creationId id="{E755C162-C11A-4144-946C-014E885EA8ED}"/>
               </a:ext>
             </a:extLst>
           </p:cNvPr>
@@ -5394,7 +5399,7 @@
           <p:cNvPr id="12" name="growth-text-92">
             <a:extLst>
               <a:ext uri="{FF2B5EF4-FFF2-40B4-BE49-F238E27FC236}">
-                <ns2:creationId id="{54B5DB45-05F4-445F-9DB9-83409CDC8CBE}"/>
+                <ns2:creationId id="{B9FF4F71-A4B1-4AA1-80D1-B03C45B8A8E0}"/>
               </a:ext>
             </a:extLst>
           </p:cNvPr>
@@ -5482,7 +5487,7 @@
           <p:cNvPr id="13" name="growth-text-93">
             <a:extLst>
               <a:ext uri="{FF2B5EF4-FFF2-40B4-BE49-F238E27FC236}">
-                <ns2:creationId id="{869F0E61-4F07-4B14-A835-C30354694D65}"/>
+                <ns2:creationId id="{752AC372-A88B-4BCA-BD0E-A72BBE913287}"/>
               </a:ext>
             </a:extLst>
           </p:cNvPr>
@@ -5547,7 +5552,7 @@
           <p:nvPr/>
         </p:nvPicPr>
         <p:blipFill>
-          <a:blip r:embed="Rd57adb5a29fe40f2">
+          <a:blip r:embed="Raf8d05f973fa4d81">
             <a:extLst>
               <a:ext uri="{96DAC541-7B7A-43D3-8B79-37D633B846F1}">
                 <asvg:svgBlip r:embed="rIdVector1"/>
@@ -5569,7 +5574,7 @@
     </p:spTree>
     <p:extLst>
       <p:ext uri="{BB962C8B-B14F-4D97-AF65-F5344CB8AC3E}">
-        <ns5:creationId val="854885841"/>
+        <ns5:creationId val="3129045"/>
       </p:ext>
     </p:extLst>
   </p:cSld>
@@ -5604,7 +5609,7 @@
           <p:nvPr/>
         </p:nvPicPr>
         <p:blipFill>
-          <a:blip r:embed="R6e34a01ce4da4957">
+          <a:blip r:embed="Rdae6cf7b4ebf466d">
             <a:extLst>
               <a:ext uri="{96DAC541-7B7A-43D3-8B79-37D633B846F1}">
                 <asvg:svgBlip r:embed="rIdVector1"/>
@@ -5628,7 +5633,7 @@
           <p:cNvPr id="2" name="closing-text-94">
             <a:extLst>
               <a:ext uri="{FF2B5EF4-FFF2-40B4-BE49-F238E27FC236}">
-                <ns4:creationId id="{40C98643-5D77-4C76-8B49-5EFD4704DEBC}"/>
+                <ns4:creationId id="{A565D111-3438-46CC-B1F2-F73E1E8F8067}"/>
               </a:ext>
             </a:extLst>
           </p:cNvPr>
@@ -5689,7 +5694,7 @@
           <p:cNvPr id="3" name="closing-text-95">
             <a:extLst>
               <a:ext uri="{FF2B5EF4-FFF2-40B4-BE49-F238E27FC236}">
-                <ns4:creationId id="{5471A912-4610-4D28-84A7-9AC172FCD1EB}"/>
+                <ns4:creationId id="{8AA046A0-40C6-460C-90A6-FBEC9BE909A7}"/>
               </a:ext>
             </a:extLst>
           </p:cNvPr>
@@ -5777,7 +5782,7 @@
           <p:cNvPr id="4" name="closing-text-96">
             <a:extLst>
               <a:ext uri="{FF2B5EF4-FFF2-40B4-BE49-F238E27FC236}">
-                <ns4:creationId id="{05C1C945-FE82-4832-9366-D6EB73D6BC68}"/>
+                <ns4:creationId id="{AF119660-8B1E-4799-B3CE-B9F3786C072D}"/>
               </a:ext>
             </a:extLst>
           </p:cNvPr>
@@ -5838,7 +5843,7 @@
           <p:cNvPr id="5" name="closing-text-97">
             <a:extLst>
               <a:ext uri="{FF2B5EF4-FFF2-40B4-BE49-F238E27FC236}">
-                <ns4:creationId id="{0FBC18FC-0B29-417B-B959-FB6B62FC839D}"/>
+                <ns4:creationId id="{08BC79CE-BD45-47BA-8EAC-BF7411A6DEAD}"/>
               </a:ext>
             </a:extLst>
           </p:cNvPr>
@@ -5903,7 +5908,7 @@
           <p:nvPr/>
         </p:nvPicPr>
         <p:blipFill>
-          <a:blip r:embed="R07d32eada7e04aac">
+          <a:blip r:embed="R53986193d2ce4dbb">
             <a:extLst>
               <a:ext uri="{96DAC541-7B7A-43D3-8B79-37D633B846F1}">
                 <asvg:svgBlip r:embed="rIdVector2"/>
@@ -5925,7 +5930,7 @@
     </p:spTree>
     <p:extLst>
       <p:ext uri="{BB962C8B-B14F-4D97-AF65-F5344CB8AC3E}">
-        <ns5:creationId val="895472972"/>
+        <ns5:creationId val="657925411"/>
       </p:ext>
     </p:extLst>
   </p:cSld>
@@ -5956,7 +5961,7 @@
           <p:cNvPr id="3" name="problem-text-4">
             <a:extLst>
               <a:ext uri="{FF2B5EF4-FFF2-40B4-BE49-F238E27FC236}">
-                <ns2:creationId id="{B8DBC50A-5725-425E-850C-80C87E6BC41F}"/>
+                <ns2:creationId id="{D6498CA0-2EFB-4F22-94F5-1DBE5EE174F5}"/>
               </a:ext>
             </a:extLst>
           </p:cNvPr>
@@ -6021,7 +6026,7 @@
           <p:nvPr/>
         </p:nvPicPr>
         <p:blipFill>
-          <a:blip r:embed="R9e9a56db03fa4849">
+          <a:blip r:embed="Rd8338bf1503a48d9">
             <a:extLst>
               <a:ext uri="{96DAC541-7B7A-43D3-8B79-37D633B846F1}">
                 <asvg:svgBlip r:embed="rIdVector1"/>
@@ -6043,7 +6048,7 @@
     </p:spTree>
     <p:extLst>
       <p:ext uri="{BB962C8B-B14F-4D97-AF65-F5344CB8AC3E}">
-        <ns5:creationId val="781125855"/>
+        <ns5:creationId val="337848877"/>
       </p:ext>
     </p:extLst>
   </p:cSld>
@@ -6074,7 +6079,7 @@
           <p:cNvPr id="21" name="audience-text-5">
             <a:extLst>
               <a:ext uri="{FF2B5EF4-FFF2-40B4-BE49-F238E27FC236}">
-                <ns2:creationId id="{989F66BD-5472-4220-BBBE-7E9437F910AF}"/>
+                <ns2:creationId id="{C5BEBE18-0B22-4EC2-A4EB-DD87F3B5DBD3}"/>
               </a:ext>
             </a:extLst>
           </p:cNvPr>
@@ -6135,7 +6140,7 @@
           <p:cNvPr id="2" name="">
             <a:extLst>
               <a:ext uri="{FF2B5EF4-FFF2-40B4-BE49-F238E27FC236}">
-                <ns2:creationId id="{37FF397C-FC45-4218-A26D-4EB9CC9FFDA6}"/>
+                <ns2:creationId id="{6A1D1ABB-DB31-4579-856C-E87D840BE358}"/>
               </a:ext>
             </a:extLst>
           </p:cNvPr>
@@ -6165,7 +6170,7 @@
           <p:cNvPr id="3" name="audience-text-6">
             <a:extLst>
               <a:ext uri="{FF2B5EF4-FFF2-40B4-BE49-F238E27FC236}">
-                <ns2:creationId id="{22320270-CD1B-480A-88E9-D1E238F38FED}"/>
+                <ns2:creationId id="{983FB5B0-4AA8-44C1-9977-6046846AC490}"/>
               </a:ext>
             </a:extLst>
           </p:cNvPr>
@@ -6226,7 +6231,7 @@
           <p:cNvPr id="4" name="audience-text-7">
             <a:extLst>
               <a:ext uri="{FF2B5EF4-FFF2-40B4-BE49-F238E27FC236}">
-                <ns2:creationId id="{2AA5327C-C648-40DD-B0FB-8FC0FC21403A}"/>
+                <ns2:creationId id="{DE567A44-420F-4EC1-9424-807E98BD470B}"/>
               </a:ext>
             </a:extLst>
           </p:cNvPr>
@@ -6287,7 +6292,7 @@
           <p:cNvPr id="5" name="audience-text-8">
             <a:extLst>
               <a:ext uri="{FF2B5EF4-FFF2-40B4-BE49-F238E27FC236}">
-                <ns2:creationId id="{CE30BD7B-2F75-4C80-B4F0-613F9FFA6DC3}"/>
+                <ns2:creationId id="{70068866-BC9C-46C6-8A95-BE6DD24370EE}"/>
               </a:ext>
             </a:extLst>
           </p:cNvPr>
@@ -6348,7 +6353,7 @@
           <p:cNvPr id="6" name="">
             <a:extLst>
               <a:ext uri="{FF2B5EF4-FFF2-40B4-BE49-F238E27FC236}">
-                <ns2:creationId id="{FE4E4323-413C-4FBC-8E0F-3682BCEAA9EF}"/>
+                <ns2:creationId id="{44365B38-C383-4E0C-B973-26C56046A8C7}"/>
               </a:ext>
             </a:extLst>
           </p:cNvPr>
@@ -6378,7 +6383,7 @@
           <p:cNvPr id="7" name="audience-text-9">
             <a:extLst>
               <a:ext uri="{FF2B5EF4-FFF2-40B4-BE49-F238E27FC236}">
-                <ns2:creationId id="{5CE89BC6-51A9-4AA9-89C0-CA1A8C96A828}"/>
+                <ns2:creationId id="{BCD53323-0C8F-4917-A083-BC3E7BD4CBEA}"/>
               </a:ext>
             </a:extLst>
           </p:cNvPr>
@@ -6439,7 +6444,7 @@
           <p:cNvPr id="8" name="audience-text-10">
             <a:extLst>
               <a:ext uri="{FF2B5EF4-FFF2-40B4-BE49-F238E27FC236}">
-                <ns2:creationId id="{8A2AF448-CE17-4B0C-8F1C-62EBFF648E17}"/>
+                <ns2:creationId id="{004EA8FE-A8EB-4418-9F80-7621BBCA2BB6}"/>
               </a:ext>
             </a:extLst>
           </p:cNvPr>
@@ -6500,7 +6505,7 @@
           <p:cNvPr id="9" name="audience-text-11">
             <a:extLst>
               <a:ext uri="{FF2B5EF4-FFF2-40B4-BE49-F238E27FC236}">
-                <ns2:creationId id="{0DF5C629-B471-46E1-9F18-103F05E64DDA}"/>
+                <ns2:creationId id="{0AD911DB-E7F2-4B07-A595-49B55444D3B3}"/>
               </a:ext>
             </a:extLst>
           </p:cNvPr>
@@ -6561,7 +6566,7 @@
           <p:cNvPr id="10" name="">
             <a:extLst>
               <a:ext uri="{FF2B5EF4-FFF2-40B4-BE49-F238E27FC236}">
-                <ns2:creationId id="{5E117B31-5D7D-4BCD-B3FD-3350A74A84DB}"/>
+                <ns2:creationId id="{071A42AD-32C8-40A6-9138-6A45ED6764E7}"/>
               </a:ext>
             </a:extLst>
           </p:cNvPr>
@@ -6591,7 +6596,7 @@
           <p:cNvPr id="11" name="audience-text-12">
             <a:extLst>
               <a:ext uri="{FF2B5EF4-FFF2-40B4-BE49-F238E27FC236}">
-                <ns2:creationId id="{211DD416-4C6E-4CC8-BA92-DA98F18EE6B3}"/>
+                <ns2:creationId id="{C2117A6A-6C34-47D5-AD02-A92107FF2074}"/>
               </a:ext>
             </a:extLst>
           </p:cNvPr>
@@ -6652,7 +6657,7 @@
           <p:cNvPr id="12" name="audience-text-13">
             <a:extLst>
               <a:ext uri="{FF2B5EF4-FFF2-40B4-BE49-F238E27FC236}">
-                <ns2:creationId id="{D147B053-211E-4CAE-AFE9-343E240E26E7}"/>
+                <ns2:creationId id="{BEBB06DA-6914-44DD-85A2-8B261268245B}"/>
               </a:ext>
             </a:extLst>
           </p:cNvPr>
@@ -6713,7 +6718,7 @@
           <p:cNvPr id="13" name="audience-text-14">
             <a:extLst>
               <a:ext uri="{FF2B5EF4-FFF2-40B4-BE49-F238E27FC236}">
-                <ns2:creationId id="{C1B791E0-715A-44E7-9089-D236FDBF77BD}"/>
+                <ns2:creationId id="{C369B393-5F78-4592-907E-7468924871D3}"/>
               </a:ext>
             </a:extLst>
           </p:cNvPr>
@@ -6774,7 +6779,7 @@
           <p:cNvPr id="14" name="">
             <a:extLst>
               <a:ext uri="{FF2B5EF4-FFF2-40B4-BE49-F238E27FC236}">
-                <ns2:creationId id="{9030F30F-F324-46DB-A9F8-394571C0F6C2}"/>
+                <ns2:creationId id="{BC78A0E8-B698-4D59-8B01-E09D33021781}"/>
               </a:ext>
             </a:extLst>
           </p:cNvPr>
@@ -6804,7 +6809,7 @@
           <p:cNvPr id="15" name="audience-text-15">
             <a:extLst>
               <a:ext uri="{FF2B5EF4-FFF2-40B4-BE49-F238E27FC236}">
-                <ns2:creationId id="{35C36B71-C6DC-4B8C-A2EF-110CCCA69809}"/>
+                <ns2:creationId id="{B3D7D140-46FE-49AC-9B46-F15C1E708109}"/>
               </a:ext>
             </a:extLst>
           </p:cNvPr>
@@ -6865,7 +6870,7 @@
           <p:cNvPr id="16" name="audience-text-16">
             <a:extLst>
               <a:ext uri="{FF2B5EF4-FFF2-40B4-BE49-F238E27FC236}">
-                <ns2:creationId id="{7101AF57-589B-4B68-A55D-5CEE854BEA25}"/>
+                <ns2:creationId id="{5E561427-489C-4586-B13E-EE9530D9C3AE}"/>
               </a:ext>
             </a:extLst>
           </p:cNvPr>
@@ -6926,7 +6931,7 @@
           <p:cNvPr id="17" name="audience-text-17">
             <a:extLst>
               <a:ext uri="{FF2B5EF4-FFF2-40B4-BE49-F238E27FC236}">
-                <ns2:creationId id="{6A89BEF7-67E1-4C4F-815A-75DCEF122C3A}"/>
+                <ns2:creationId id="{BB3B7FC0-71CD-48BB-94BE-4471B70772B9}"/>
               </a:ext>
             </a:extLst>
           </p:cNvPr>
@@ -6987,7 +6992,7 @@
           <p:cNvPr id="18" name="audience-text-18">
             <a:extLst>
               <a:ext uri="{FF2B5EF4-FFF2-40B4-BE49-F238E27FC236}">
-                <ns2:creationId id="{BE4D5494-8A96-4D62-8E5D-BFAD6CAA4B38}"/>
+                <ns2:creationId id="{6B958817-4B63-4040-BE61-33F853269774}"/>
               </a:ext>
             </a:extLst>
           </p:cNvPr>
@@ -7075,7 +7080,7 @@
           <p:cNvPr id="19" name="audience-text-19">
             <a:extLst>
               <a:ext uri="{FF2B5EF4-FFF2-40B4-BE49-F238E27FC236}">
-                <ns2:creationId id="{DDF44F7D-391B-4CD2-B8BF-CAC8911779A3}"/>
+                <ns2:creationId id="{99B5818C-CA84-4E66-AED1-18AAC9FEDE68}"/>
               </a:ext>
             </a:extLst>
           </p:cNvPr>
@@ -7140,7 +7145,7 @@
           <p:nvPr/>
         </p:nvPicPr>
         <p:blipFill>
-          <a:blip r:embed="R88849a67c3404311">
+          <a:blip r:embed="R0b7dc96b011540ac">
             <a:extLst>
               <a:ext uri="{96DAC541-7B7A-43D3-8B79-37D633B846F1}">
                 <asvg:svgBlip r:embed="rIdVector1"/>
@@ -7162,7 +7167,7 @@
     </p:spTree>
     <p:extLst>
       <p:ext uri="{BB962C8B-B14F-4D97-AF65-F5344CB8AC3E}">
-        <ns5:creationId val="326788758"/>
+        <ns5:creationId val="2021780685"/>
       </p:ext>
     </p:extLst>
   </p:cSld>
@@ -7193,7 +7198,7 @@
           <p:cNvPr id="4" name="agent-text-20">
             <a:extLst>
               <a:ext uri="{FF2B5EF4-FFF2-40B4-BE49-F238E27FC236}">
-                <ns2:creationId id="{3BB43D68-9296-4F83-B516-6552F0D1301D}"/>
+                <ns2:creationId id="{62D13AA6-06FA-438D-823B-29431D85FA3D}"/>
               </a:ext>
             </a:extLst>
           </p:cNvPr>
@@ -7254,7 +7259,7 @@
           <p:cNvPr id="2" name="agent-text-21">
             <a:extLst>
               <a:ext uri="{FF2B5EF4-FFF2-40B4-BE49-F238E27FC236}">
-                <ns2:creationId id="{F0370B83-C03B-467B-84F9-D961C1ED53D4}"/>
+                <ns2:creationId id="{D0C1F612-6228-4F36-A3F3-C3C8888835BE}"/>
               </a:ext>
             </a:extLst>
           </p:cNvPr>
@@ -7319,7 +7324,7 @@
           <p:nvPr/>
         </p:nvPicPr>
         <p:blipFill>
-          <a:blip r:embed="R9da5a8696f284a26">
+          <a:blip r:embed="R241df50651b8471a">
             <a:extLst>
               <a:ext uri="{96DAC541-7B7A-43D3-8B79-37D633B846F1}">
                 <asvg:svgBlip r:embed="rIdVector1"/>
@@ -7342,7 +7347,7 @@
     </p:spTree>
     <p:extLst>
       <p:ext uri="{BB962C8B-B14F-4D97-AF65-F5344CB8AC3E}">
-        <ns5:creationId val="1730098357"/>
+        <ns5:creationId val="581541787"/>
       </p:ext>
     </p:extLst>
   </p:cSld>
@@ -7373,7 +7378,7 @@
           <p:cNvPr id="4" name="journey-text-22">
             <a:extLst>
               <a:ext uri="{FF2B5EF4-FFF2-40B4-BE49-F238E27FC236}">
-                <ns2:creationId id="{2FB1920A-4146-44DE-811C-6464B13779BE}"/>
+                <ns2:creationId id="{6A5ADEFE-ACFE-4288-B149-D4D42F2EA301}"/>
               </a:ext>
             </a:extLst>
           </p:cNvPr>
@@ -7434,7 +7439,7 @@
           <p:cNvPr id="2" name="journey-text-23">
             <a:extLst>
               <a:ext uri="{FF2B5EF4-FFF2-40B4-BE49-F238E27FC236}">
-                <ns2:creationId id="{A981073C-16E7-4E21-9816-7AFEE906A333}"/>
+                <ns2:creationId id="{5FC7169D-5021-47AF-8007-C12C7D3CFBFD}"/>
               </a:ext>
             </a:extLst>
           </p:cNvPr>
@@ -7499,7 +7504,7 @@
           <p:nvPr/>
         </p:nvPicPr>
         <p:blipFill>
-          <a:blip r:embed="R1a385bbd50dd4e04">
+          <a:blip r:embed="Reea92db763c140d5">
             <a:extLst>
               <a:ext uri="{96DAC541-7B7A-43D3-8B79-37D633B846F1}">
                 <asvg:svgBlip r:embed="rIdVector1"/>
@@ -7522,7 +7527,7 @@
     </p:spTree>
     <p:extLst>
       <p:ext uri="{BB962C8B-B14F-4D97-AF65-F5344CB8AC3E}">
-        <ns5:creationId val="350904256"/>
+        <ns5:creationId val="913076696"/>
       </p:ext>
     </p:extLst>
   </p:cSld>
@@ -7553,7 +7558,7 @@
           <p:cNvPr id="14" name="responsibilities-text-24">
             <a:extLst>
               <a:ext uri="{FF2B5EF4-FFF2-40B4-BE49-F238E27FC236}">
-                <ns2:creationId id="{52CE62DF-9E0F-4556-945C-C9AE9AC3CBBA}"/>
+                <ns2:creationId id="{2A2A3742-3D66-4524-89D3-F310B2E59B30}"/>
               </a:ext>
             </a:extLst>
           </p:cNvPr>
@@ -7614,7 +7619,7 @@
           <p:cNvPr id="2" name="responsibilities-text-25">
             <a:extLst>
               <a:ext uri="{FF2B5EF4-FFF2-40B4-BE49-F238E27FC236}">
-                <ns2:creationId id="{CA9E79B4-203A-4B18-9580-5FE39B51FCA4}"/>
+                <ns2:creationId id="{1E1C9815-15BD-4FC8-809C-87BAAF17E719}"/>
               </a:ext>
             </a:extLst>
           </p:cNvPr>
@@ -7679,7 +7684,7 @@
           <p:nvPr/>
         </p:nvPicPr>
         <p:blipFill>
-          <a:blip r:embed="R47adb9f83a4846df">
+          <a:blip r:embed="Rdab21e54e5584a22">
             <a:extLst>
               <a:ext uri="{96DAC541-7B7A-43D3-8B79-37D633B846F1}">
                 <asvg:svgBlip r:embed="rIdVector1"/>
@@ -7703,7 +7708,7 @@
           <p:cNvPr id="4" name="responsibilities-text-26">
             <a:extLst>
               <a:ext uri="{FF2B5EF4-FFF2-40B4-BE49-F238E27FC236}">
-                <ns2:creationId id="{EFE6D6C5-6417-4E91-921A-B1B554FCB310}"/>
+                <ns2:creationId id="{FB9258C8-9575-4874-91C9-E05E209D2DBB}"/>
               </a:ext>
             </a:extLst>
           </p:cNvPr>
@@ -7764,7 +7769,7 @@
           <p:cNvPr id="5" name="responsibilities-text-27">
             <a:extLst>
               <a:ext uri="{FF2B5EF4-FFF2-40B4-BE49-F238E27FC236}">
-                <ns2:creationId id="{5CACB177-3A1B-40D3-A369-B24C3D347432}"/>
+                <ns2:creationId id="{0526A4A8-C971-4648-9B3E-7034DD03D308}"/>
               </a:ext>
             </a:extLst>
           </p:cNvPr>
@@ -7825,7 +7830,7 @@
           <p:cNvPr id="6" name="">
             <a:extLst>
               <a:ext uri="{FF2B5EF4-FFF2-40B4-BE49-F238E27FC236}">
-                <ns2:creationId id="{42F1E685-BE45-4037-8FD7-4AF1245FFD90}"/>
+                <ns2:creationId id="{AE3516C2-2207-4198-96CF-102F66FD85F4}"/>
               </a:ext>
             </a:extLst>
           </p:cNvPr>
@@ -7855,7 +7860,7 @@
           <p:cNvPr id="7" name="responsibilities-text-28">
             <a:extLst>
               <a:ext uri="{FF2B5EF4-FFF2-40B4-BE49-F238E27FC236}">
-                <ns2:creationId id="{1471E9B6-0661-47CC-9D95-B64476A08BF0}"/>
+                <ns2:creationId id="{D27AAD72-EE57-45C7-97F8-A9EB4DA77C41}"/>
               </a:ext>
             </a:extLst>
           </p:cNvPr>
@@ -7916,7 +7921,7 @@
           <p:cNvPr id="8" name="responsibilities-text-29">
             <a:extLst>
               <a:ext uri="{FF2B5EF4-FFF2-40B4-BE49-F238E27FC236}">
-                <ns2:creationId id="{3426F0AE-8AB6-4A9F-89FF-EFE21489BDD1}"/>
+                <ns2:creationId id="{6267663B-D37C-495A-9464-ADA1C6F93DE5}"/>
               </a:ext>
             </a:extLst>
           </p:cNvPr>
@@ -7977,7 +7982,7 @@
           <p:cNvPr id="9" name="responsibilities-text-30">
             <a:extLst>
               <a:ext uri="{FF2B5EF4-FFF2-40B4-BE49-F238E27FC236}">
-                <ns2:creationId id="{0BA167F2-8783-4FA1-9CA6-A7BD1CBA9B8F}"/>
+                <ns2:creationId id="{EA5A1233-4EDB-4950-90C3-9E2785E7FCF2}"/>
               </a:ext>
             </a:extLst>
           </p:cNvPr>
@@ -8038,7 +8043,7 @@
           <p:cNvPr id="10" name="responsibilities-text-31">
             <a:extLst>
               <a:ext uri="{FF2B5EF4-FFF2-40B4-BE49-F238E27FC236}">
-                <ns2:creationId id="{62B222A5-DA37-4DC2-80FB-610A03CB9B92}"/>
+                <ns2:creationId id="{C91DF7F8-DB11-45BC-BA6A-5602D0964B1E}"/>
               </a:ext>
             </a:extLst>
           </p:cNvPr>
@@ -8099,7 +8104,7 @@
           <p:cNvPr id="11" name="responsibilities-text-32">
             <a:extLst>
               <a:ext uri="{FF2B5EF4-FFF2-40B4-BE49-F238E27FC236}">
-                <ns2:creationId id="{6FD4AF66-3338-4654-9136-E06ACF689DB5}"/>
+                <ns2:creationId id="{D87FC334-6990-41D8-941F-D05F56F153FA}"/>
               </a:ext>
             </a:extLst>
           </p:cNvPr>
@@ -8160,7 +8165,7 @@
           <p:cNvPr id="12" name="responsibilities-text-33">
             <a:extLst>
               <a:ext uri="{FF2B5EF4-FFF2-40B4-BE49-F238E27FC236}">
-                <ns2:creationId id="{EA83E65A-95A1-4DD4-B519-42AE0FBDA287}"/>
+                <ns2:creationId id="{DF6B6972-1F3D-4E05-9610-2C49A541A633}"/>
               </a:ext>
             </a:extLst>
           </p:cNvPr>
@@ -8221,7 +8226,7 @@
           <p:cNvPr id="13" name="responsibilities-text-34">
             <a:extLst>
               <a:ext uri="{FF2B5EF4-FFF2-40B4-BE49-F238E27FC236}">
-                <ns2:creationId id="{BEB816C8-1C03-4B6D-8888-FDF8236588DC}"/>
+                <ns2:creationId id="{9E47E0CB-6AEA-4FF8-B39B-82505BEFD968}"/>
               </a:ext>
             </a:extLst>
           </p:cNvPr>
@@ -8280,7 +8285,7 @@
     </p:spTree>
     <p:extLst>
       <p:ext uri="{BB962C8B-B14F-4D97-AF65-F5344CB8AC3E}">
-        <ns5:creationId val="1153091694"/>
+        <ns5:creationId val="823820363"/>
       </p:ext>
     </p:extLst>
   </p:cSld>
@@ -8311,7 +8316,7 @@
           <p:cNvPr id="4" name="architecture-text-35">
             <a:extLst>
               <a:ext uri="{FF2B5EF4-FFF2-40B4-BE49-F238E27FC236}">
-                <ns2:creationId id="{3EF17862-2E5A-4D07-8DE0-1FC02059A4FA}"/>
+                <ns2:creationId id="{32AD33E0-76E6-4A8D-81EB-4EDD9D652832}"/>
               </a:ext>
             </a:extLst>
           </p:cNvPr>
@@ -8372,7 +8377,7 @@
           <p:cNvPr id="2" name="architecture-text-36">
             <a:extLst>
               <a:ext uri="{FF2B5EF4-FFF2-40B4-BE49-F238E27FC236}">
-                <ns2:creationId id="{837D337D-5AD3-40BD-AC0B-E62B9A17EA7C}"/>
+                <ns2:creationId id="{5585530B-5EE5-4B45-B4F8-764539102D19}"/>
               </a:ext>
             </a:extLst>
           </p:cNvPr>
@@ -8437,7 +8442,7 @@
           <p:nvPr/>
         </p:nvPicPr>
         <p:blipFill>
-          <a:blip r:embed="R9aa1c5c320b7463d">
+          <a:blip r:embed="R4376a0d31ffd44b9">
             <a:extLst>
               <a:ext uri="{96DAC541-7B7A-43D3-8B79-37D633B846F1}">
                 <asvg:svgBlip r:embed="rIdVector1"/>
@@ -8460,7 +8465,7 @@
     </p:spTree>
     <p:extLst>
       <p:ext uri="{BB962C8B-B14F-4D97-AF65-F5344CB8AC3E}">
-        <ns5:creationId val="1438076427"/>
+        <ns5:creationId val="1808097496"/>
       </p:ext>
     </p:extLst>
   </p:cSld>
@@ -8491,7 +8496,7 @@
           <p:cNvPr id="15" name="safety-text-37">
             <a:extLst>
               <a:ext uri="{FF2B5EF4-FFF2-40B4-BE49-F238E27FC236}">
-                <ns2:creationId id="{4ED24D12-CBC6-4A9D-8014-062634513A8B}"/>
+                <ns2:creationId id="{21535F5A-68ED-4B33-BC7D-6B457F1A08E7}"/>
               </a:ext>
             </a:extLst>
           </p:cNvPr>
@@ -8552,7 +8557,7 @@
           <p:cNvPr id="2" name="safety-text-38">
             <a:extLst>
               <a:ext uri="{FF2B5EF4-FFF2-40B4-BE49-F238E27FC236}">
-                <ns2:creationId id="{A857DC8E-4CD5-4370-8887-22859EC4E33D}"/>
+                <ns2:creationId id="{45065F1C-5615-4608-86F4-F1C99801AF0F}"/>
               </a:ext>
             </a:extLst>
           </p:cNvPr>
@@ -8617,7 +8622,7 @@
           <p:nvPr/>
         </p:nvPicPr>
         <p:blipFill>
-          <a:blip r:embed="Rebbe0afa86f34222">
+          <a:blip r:embed="R353fac31e5b04094">
             <a:extLst>
               <a:ext uri="{96DAC541-7B7A-43D3-8B79-37D633B846F1}">
                 <asvg:svgBlip r:embed="rIdVector1"/>
@@ -8641,7 +8646,7 @@
           <p:cNvPr id="4" name="safety-text-39">
             <a:extLst>
               <a:ext uri="{FF2B5EF4-FFF2-40B4-BE49-F238E27FC236}">
-                <ns2:creationId id="{CEBD0A0A-F694-489B-B186-287ED5214EA8}"/>
+                <ns2:creationId id="{6E4F9AE4-A5DA-4A3D-B6E5-393B7C153F1F}"/>
               </a:ext>
             </a:extLst>
           </p:cNvPr>
@@ -8702,7 +8707,7 @@
           <p:cNvPr id="5" name="safety-text-40">
             <a:extLst>
               <a:ext uri="{FF2B5EF4-FFF2-40B4-BE49-F238E27FC236}">
-                <ns2:creationId id="{9D42219F-4105-43FD-94A9-12187E9C25A7}"/>
+                <ns2:creationId id="{D505E194-58A2-4175-B140-25FC764DB9FA}"/>
               </a:ext>
             </a:extLst>
           </p:cNvPr>
@@ -8763,7 +8768,7 @@
           <p:cNvPr id="6" name="safety-text-41">
             <a:extLst>
               <a:ext uri="{FF2B5EF4-FFF2-40B4-BE49-F238E27FC236}">
-                <ns2:creationId id="{A1445615-D329-417C-9FAC-E73BF6068549}"/>
+                <ns2:creationId id="{C399FC2E-A165-4632-835B-D93851CA55E5}"/>
               </a:ext>
             </a:extLst>
           </p:cNvPr>
@@ -8824,7 +8829,7 @@
           <p:cNvPr id="7" name="safety-text-42">
             <a:extLst>
               <a:ext uri="{FF2B5EF4-FFF2-40B4-BE49-F238E27FC236}">
-                <ns2:creationId id="{9790C081-02D6-4046-B321-EA16401678B0}"/>
+                <ns2:creationId id="{A093098C-6626-41D3-BAE5-1A21FB7D97FB}"/>
               </a:ext>
             </a:extLst>
           </p:cNvPr>
@@ -8885,7 +8890,7 @@
           <p:cNvPr id="8" name="safety-text-43">
             <a:extLst>
               <a:ext uri="{FF2B5EF4-FFF2-40B4-BE49-F238E27FC236}">
-                <ns2:creationId id="{E7E7F372-CBEA-43B2-9154-56518CD684DA}"/>
+                <ns2:creationId id="{FCC9125A-FA8F-43A2-870E-C7C8043786E4}"/>
               </a:ext>
             </a:extLst>
           </p:cNvPr>
@@ -8946,7 +8951,7 @@
           <p:cNvPr id="9" name="safety-text-44">
             <a:extLst>
               <a:ext uri="{FF2B5EF4-FFF2-40B4-BE49-F238E27FC236}">
-                <ns2:creationId id="{82AA8F16-1C0F-4341-AC3A-F732715C811A}"/>
+                <ns2:creationId id="{8D9870A6-DEE3-4EFA-9CE6-C2E427A6822D}"/>
               </a:ext>
             </a:extLst>
           </p:cNvPr>
@@ -9007,7 +9012,7 @@
           <p:cNvPr id="10" name="safety-text-45">
             <a:extLst>
               <a:ext uri="{FF2B5EF4-FFF2-40B4-BE49-F238E27FC236}">
-                <ns2:creationId id="{C7072A9C-A89C-45CE-95BB-7F35A800D481}"/>
+                <ns2:creationId id="{E458BA7B-374E-4AAF-99BE-BAB6D5D0081E}"/>
               </a:ext>
             </a:extLst>
           </p:cNvPr>
@@ -9068,7 +9073,7 @@
           <p:cNvPr id="11" name="safety-text-46">
             <a:extLst>
               <a:ext uri="{FF2B5EF4-FFF2-40B4-BE49-F238E27FC236}">
-                <ns2:creationId id="{0843F146-E352-4931-BF78-43F996DC01A0}"/>
+                <ns2:creationId id="{AF76E951-5341-4BFF-A97D-C918DBDB4603}"/>
               </a:ext>
             </a:extLst>
           </p:cNvPr>
@@ -9129,7 +9134,7 @@
           <p:cNvPr id="12" name="safety-text-47">
             <a:extLst>
               <a:ext uri="{FF2B5EF4-FFF2-40B4-BE49-F238E27FC236}">
-                <ns2:creationId id="{AFB7F02B-2AF9-4DFA-AEBA-E77AB9DEBFB1}"/>
+                <ns2:creationId id="{DFDDF42B-80E4-4F65-A511-F1B072CB6B8D}"/>
               </a:ext>
             </a:extLst>
           </p:cNvPr>
@@ -9190,7 +9195,7 @@
           <p:cNvPr id="13" name="safety-text-48">
             <a:extLst>
               <a:ext uri="{FF2B5EF4-FFF2-40B4-BE49-F238E27FC236}">
-                <ns2:creationId id="{BEF015D7-0FA0-4E10-A91D-C67BB144FFDE}"/>
+                <ns2:creationId id="{4002BC45-88A7-4C9D-8058-9AE06215E08B}"/>
               </a:ext>
             </a:extLst>
           </p:cNvPr>
@@ -9251,7 +9256,7 @@
           <p:cNvPr id="14" name="safety-text-49">
             <a:extLst>
               <a:ext uri="{FF2B5EF4-FFF2-40B4-BE49-F238E27FC236}">
-                <ns2:creationId id="{6DB61486-E986-4441-A32F-67BBFA594B56}"/>
+                <ns2:creationId id="{B5D9622A-9639-401C-A2F9-2170838E66AE}"/>
               </a:ext>
             </a:extLst>
           </p:cNvPr>
@@ -9310,7 +9315,7 @@
     </p:spTree>
     <p:extLst>
       <p:ext uri="{BB962C8B-B14F-4D97-AF65-F5344CB8AC3E}">
-        <ns5:creationId val="1778348529"/>
+        <ns5:creationId val="334884498"/>
       </p:ext>
     </p:extLst>
   </p:cSld>
@@ -9341,7 +9346,7 @@
           <p:cNvPr id="4" name="roadmap-text-50">
             <a:extLst>
               <a:ext uri="{FF2B5EF4-FFF2-40B4-BE49-F238E27FC236}">
-                <ns2:creationId id="{BBD719F0-776E-497D-9179-14798B1FF99B}"/>
+                <ns2:creationId id="{D2853DBA-6273-4B9C-A628-C4D00000035A}"/>
               </a:ext>
             </a:extLst>
           </p:cNvPr>
@@ -9402,7 +9407,7 @@
           <p:cNvPr id="2" name="roadmap-text-51">
             <a:extLst>
               <a:ext uri="{FF2B5EF4-FFF2-40B4-BE49-F238E27FC236}">
-                <ns2:creationId id="{8459A374-FC90-443F-A889-4FC2BF1967A8}"/>
+                <ns2:creationId id="{9C2D490D-4AD6-4673-A220-BD74FCF2ED51}"/>
               </a:ext>
             </a:extLst>
           </p:cNvPr>
@@ -9467,7 +9472,7 @@
           <p:nvPr/>
         </p:nvPicPr>
         <p:blipFill>
-          <a:blip r:embed="R3c02458908294853">
+          <a:blip r:embed="R55da409310ed4520">
             <a:extLst>
               <a:ext uri="{96DAC541-7B7A-43D3-8B79-37D633B846F1}">
                 <asvg:svgBlip r:embed="rIdVector1"/>
@@ -9490,7 +9495,7 @@
     </p:spTree>
     <p:extLst>
       <p:ext uri="{BB962C8B-B14F-4D97-AF65-F5344CB8AC3E}">
-        <ns5:creationId val="79736945"/>
+        <ns5:creationId val="205655016"/>
       </p:ext>
     </p:extLst>
   </p:cSld>

</xml_diff>